<commit_message>
docs: cenário enxuto de ferramentas (planos gratuitos e bot de WhatsApp próprio)
Co-Authored-By: Claude Sonnet 5.5 <noreply@anthropic.com>
Claude-Session: https://claude.ai/code/session_018P8tNa7TjbnCtoUzBLkSAJ
</commit_message>
<xml_diff>
--- a/docs/negocio/Guinchei-Custos-e-Receitas-MVP.pptx
+++ b/docs/negocio/Guinchei-Custos-e-Receitas-MVP.pptx
@@ -5757,7 +5757,7 @@
                           <a:ea typeface="Inter" pitchFamily="34" charset="-122"/>
                           <a:cs typeface="Inter" pitchFamily="34" charset="-120"/>
                         </a:rPr>
-                        <a:t>Código por WhatsApp/SMS</a:t>
+                        <a:t>Número dedicado + bot de WhatsApp</a:t>
                       </a:r>
                       <a:endParaRPr lang="en-US" sz="1300" dirty="0">
                         <a:latin typeface="Inter" charset="0"/>
@@ -5825,7 +5825,7 @@
                           <a:ea typeface="Inter" pitchFamily="34" charset="-122"/>
                           <a:cs typeface="Inter" pitchFamily="34" charset="-120"/>
                         </a:rPr>
-                        <a:t>~R$ 0,30 por código</a:t>
+                        <a:t>~R$ 40 (chip)</a:t>
                       </a:r>
                       <a:endParaRPr lang="en-US" sz="1300" dirty="0">
                         <a:latin typeface="Inter" charset="0"/>
@@ -6351,7 +6351,7 @@
                 <a:ea typeface="Space Grotesk" pitchFamily="34" charset="-122"/>
                 <a:cs typeface="Space Grotesk" pitchFamily="34" charset="-120"/>
               </a:rPr>
-              <a:t>R$ 250–500 por mês</a:t>
+              <a:t>≈ R$ 45 por mês</a:t>
             </a:r>
             <a:pPr indent="0" marL="0">
               <a:buNone/>
@@ -6365,7 +6365,7 @@
                 <a:ea typeface="Inter" pitchFamily="34" charset="-122"/>
                 <a:cs typeface="Inter" pitchFamily="34" charset="-120"/>
               </a:rPr>
-              <a:t>  em ferramentas, dentro da verba de R$ 7.000 do semestre</a:t>
+              <a:t>  no cenário enxuto; ≈ R$ 490 com planos pagos e API oficial</a:t>
             </a:r>
             <a:endParaRPr lang="en-US" sz="1400" dirty="0"/>
           </a:p>
@@ -6380,7 +6380,7 @@
         <p:spPr>
           <a:xfrm>
             <a:off x="457200" y="4498848"/>
-            <a:ext cx="5486400" cy="182880"/>
+            <a:ext cx="8229600" cy="182880"/>
           </a:xfrm>
           <a:prstGeom prst="rect">
             <a:avLst/>
@@ -6404,7 +6404,7 @@
                 <a:ea typeface="Inter" pitchFamily="34" charset="-122"/>
                 <a:cs typeface="Inter" pitchFamily="34" charset="-120"/>
               </a:rPr>
-              <a:t>Preços estimados (dólar ≈ R$ 5,50); confirmar com cotação.</a:t>
+              <a:t>Estimativas. Vercel Hobby é para uso não comercial; Supabase Free pausa por inatividade e não tem backup.</a:t>
             </a:r>
             <a:endParaRPr lang="en-US" sz="1000" dirty="0"/>
           </a:p>

</xml_diff>